<commit_message>
started overall function, translation of function parameters and column names in english, adjustments to existing functions to streamline the process
</commit_message>
<xml_diff>
--- a/Tentative_flowchart.pptx
+++ b/Tentative_flowchart.pptx
@@ -112,7 +112,7 @@
             <a:srgbClr val="A4A3A4"/>
           </p15:clr>
         </p15:guide>
-        <p15:guide id="2" pos="5670" userDrawn="1">
+        <p15:guide id="2" pos="5710" userDrawn="1">
           <p15:clr>
             <a:srgbClr val="A4A3A4"/>
           </p15:clr>
@@ -3006,7 +3006,7 @@
         </p:nvSpPr>
         <p:spPr>
           <a:xfrm>
-            <a:off x="6428761" y="544038"/>
+            <a:off x="5589926" y="3112613"/>
             <a:ext cx="1994896" cy="578407"/>
           </a:xfrm>
           <a:prstGeom prst="roundRect">
@@ -3278,7 +3278,7 @@
         </p:nvSpPr>
         <p:spPr>
           <a:xfrm>
-            <a:off x="9192260" y="4179570"/>
+            <a:off x="10738485" y="5050790"/>
             <a:ext cx="2574290" cy="578485"/>
           </a:xfrm>
           <a:prstGeom prst="roundRect">
@@ -3346,7 +3346,7 @@
         </p:nvSpPr>
         <p:spPr>
           <a:xfrm>
-            <a:off x="5640776" y="4179491"/>
+            <a:off x="6995231" y="7088426"/>
             <a:ext cx="2321129" cy="578407"/>
           </a:xfrm>
           <a:prstGeom prst="roundRect">
@@ -3485,12 +3485,12 @@
         </p:nvCxnSpPr>
         <p:spPr>
           <a:xfrm rot="5400000" flipV="1">
-            <a:off x="9960928" y="3661093"/>
-            <a:ext cx="910590" cy="126365"/>
+            <a:off x="10298430" y="3323590"/>
+            <a:ext cx="1781810" cy="1672590"/>
           </a:xfrm>
           <a:prstGeom prst="curvedConnector3">
             <a:avLst>
-              <a:gd name="adj1" fmla="val 49965"/>
+              <a:gd name="adj1" fmla="val 50000"/>
             </a:avLst>
           </a:prstGeom>
           <a:ln>
@@ -3552,42 +3552,6 @@
       </p:cxnSp>
       <p:cxnSp>
         <p:nvCxnSpPr>
-          <p:cNvPr id="22" name="Curved Connector 21"/>
-          <p:cNvCxnSpPr>
-            <a:stCxn id="10" idx="2"/>
-            <a:endCxn id="9" idx="1"/>
-          </p:cNvCxnSpPr>
-          <p:nvPr/>
-        </p:nvCxnSpPr>
-        <p:spPr>
-          <a:xfrm rot="5400000" flipV="1">
-            <a:off x="7888605" y="660400"/>
-            <a:ext cx="715010" cy="1639570"/>
-          </a:xfrm>
-          <a:prstGeom prst="curvedConnector2">
-            <a:avLst/>
-          </a:prstGeom>
-          <a:ln>
-            <a:tailEnd type="arrow" w="med" len="med"/>
-          </a:ln>
-        </p:spPr>
-        <p:style>
-          <a:lnRef idx="3">
-            <a:schemeClr val="accent1"/>
-          </a:lnRef>
-          <a:fillRef idx="0">
-            <a:srgbClr val="FFFFFF"/>
-          </a:fillRef>
-          <a:effectRef idx="0">
-            <a:srgbClr val="FFFFFF"/>
-          </a:effectRef>
-          <a:fontRef idx="minor">
-            <a:schemeClr val="tx1"/>
-          </a:fontRef>
-        </p:style>
-      </p:cxnSp>
-      <p:cxnSp>
-        <p:nvCxnSpPr>
           <p:cNvPr id="23" name="Curved Connector 22"/>
           <p:cNvCxnSpPr>
             <a:stCxn id="12" idx="2"/>
@@ -3673,12 +3637,14 @@
           <p:nvPr/>
         </p:nvCxnSpPr>
         <p:spPr>
-          <a:xfrm>
-            <a:off x="7961630" y="4469130"/>
-            <a:ext cx="1230630" cy="3175"/>
-          </a:xfrm>
-          <a:prstGeom prst="curvedConnector2">
-            <a:avLst/>
+          <a:xfrm flipV="1">
+            <a:off x="9316085" y="5340350"/>
+            <a:ext cx="1422400" cy="2037715"/>
+          </a:xfrm>
+          <a:prstGeom prst="curvedConnector3">
+            <a:avLst>
+              <a:gd name="adj1" fmla="val 50000"/>
+            </a:avLst>
           </a:prstGeom>
           <a:ln>
             <a:tailEnd type="arrow" w="med" len="med"/>
@@ -3709,13 +3675,15 @@
           <p:nvPr/>
         </p:nvCxnSpPr>
         <p:spPr>
-          <a:xfrm rot="10800000" flipV="1">
-            <a:off x="11766550" y="2979420"/>
-            <a:ext cx="742315" cy="1489710"/>
-          </a:xfrm>
-          <a:prstGeom prst="curvedConnector3">
+          <a:xfrm rot="10800000" flipH="1" flipV="1">
+            <a:off x="12508865" y="2979420"/>
+            <a:ext cx="803910" cy="2360930"/>
+          </a:xfrm>
+          <a:prstGeom prst="curvedConnector5">
             <a:avLst>
-              <a:gd name="adj1" fmla="val 49957"/>
+              <a:gd name="adj1" fmla="val -29621"/>
+              <a:gd name="adj2" fmla="val 50000"/>
+              <a:gd name="adj3" fmla="val 129621"/>
             </a:avLst>
           </a:prstGeom>
           <a:ln>
@@ -3737,42 +3705,6 @@
           </a:fontRef>
         </p:style>
       </p:cxnSp>
-      <p:cxnSp>
-        <p:nvCxnSpPr>
-          <p:cNvPr id="28" name="Curved Connector 27"/>
-          <p:cNvCxnSpPr>
-            <a:stCxn id="10" idx="2"/>
-            <a:endCxn id="14" idx="1"/>
-          </p:cNvCxnSpPr>
-          <p:nvPr/>
-        </p:nvCxnSpPr>
-        <p:spPr>
-          <a:xfrm rot="5400000" flipV="1">
-            <a:off x="6636068" y="1912938"/>
-            <a:ext cx="3346450" cy="1765935"/>
-          </a:xfrm>
-          <a:prstGeom prst="curvedConnector2">
-            <a:avLst/>
-          </a:prstGeom>
-          <a:ln>
-            <a:tailEnd type="arrow" w="med" len="med"/>
-          </a:ln>
-        </p:spPr>
-        <p:style>
-          <a:lnRef idx="3">
-            <a:schemeClr val="accent1"/>
-          </a:lnRef>
-          <a:fillRef idx="0">
-            <a:srgbClr val="FFFFFF"/>
-          </a:fillRef>
-          <a:effectRef idx="0">
-            <a:srgbClr val="FFFFFF"/>
-          </a:effectRef>
-          <a:fontRef idx="minor">
-            <a:schemeClr val="tx1"/>
-          </a:fontRef>
-        </p:style>
-      </p:cxnSp>
       <p:sp>
         <p:nvSpPr>
           <p:cNvPr id="29" name="Rounded Rectangle 28"/>
@@ -3781,7 +3713,7 @@
         </p:nvSpPr>
         <p:spPr>
           <a:xfrm>
-            <a:off x="9495698" y="5321778"/>
+            <a:off x="11041923" y="6192998"/>
             <a:ext cx="1841154" cy="578407"/>
           </a:xfrm>
           <a:prstGeom prst="roundRect">
@@ -3849,7 +3781,7 @@
         </p:nvSpPr>
         <p:spPr>
           <a:xfrm>
-            <a:off x="8712200" y="6576060"/>
+            <a:off x="9192260" y="8285480"/>
             <a:ext cx="3385820" cy="578485"/>
           </a:xfrm>
           <a:prstGeom prst="roundRect">
@@ -3917,7 +3849,7 @@
         </p:nvSpPr>
         <p:spPr>
           <a:xfrm>
-            <a:off x="13141325" y="6576060"/>
+            <a:off x="13425805" y="8285480"/>
             <a:ext cx="3028950" cy="578485"/>
           </a:xfrm>
           <a:prstGeom prst="roundRect">
@@ -3988,12 +3920,12 @@
         </p:nvCxnSpPr>
         <p:spPr>
           <a:xfrm rot="5400000">
-            <a:off x="10072370" y="6232525"/>
-            <a:ext cx="675640" cy="10795"/>
+            <a:off x="10667048" y="6989763"/>
+            <a:ext cx="1513840" cy="1077595"/>
           </a:xfrm>
           <a:prstGeom prst="curvedConnector3">
             <a:avLst>
-              <a:gd name="adj1" fmla="val 49953"/>
+              <a:gd name="adj1" fmla="val 49979"/>
             </a:avLst>
           </a:prstGeom>
           <a:ln>
@@ -4026,7 +3958,7 @@
         </p:nvCxnSpPr>
         <p:spPr>
           <a:xfrm rot="5400000">
-            <a:off x="10165715" y="5008245"/>
+            <a:off x="11711940" y="5879465"/>
             <a:ext cx="563880" cy="63500"/>
           </a:xfrm>
           <a:prstGeom prst="curvedConnector3">
@@ -4061,7 +3993,7 @@
         </p:nvSpPr>
         <p:spPr>
           <a:xfrm>
-            <a:off x="2752725" y="8875395"/>
+            <a:off x="2752725" y="9453880"/>
             <a:ext cx="3385820" cy="578485"/>
           </a:xfrm>
           <a:prstGeom prst="roundRect">
@@ -4132,8 +4064,8 @@
         </p:nvCxnSpPr>
         <p:spPr>
           <a:xfrm rot="5400000" flipV="1">
-            <a:off x="6703060" y="4856480"/>
-            <a:ext cx="2107565" cy="1910715"/>
+            <a:off x="8220075" y="7602855"/>
+            <a:ext cx="908050" cy="1036320"/>
           </a:xfrm>
           <a:prstGeom prst="curvedConnector2">
             <a:avLst/>
@@ -4168,12 +4100,12 @@
         </p:nvCxnSpPr>
         <p:spPr>
           <a:xfrm rot="5400000">
-            <a:off x="3564890" y="5638800"/>
-            <a:ext cx="4117340" cy="2355850"/>
+            <a:off x="5407343" y="6705283"/>
+            <a:ext cx="1786890" cy="3710305"/>
           </a:xfrm>
           <a:prstGeom prst="curvedConnector3">
             <a:avLst>
-              <a:gd name="adj1" fmla="val 50000"/>
+              <a:gd name="adj1" fmla="val 49982"/>
             </a:avLst>
           </a:prstGeom>
           <a:ln>
@@ -4203,7 +4135,7 @@
         </p:nvSpPr>
         <p:spPr>
           <a:xfrm>
-            <a:off x="1018540" y="7425690"/>
+            <a:off x="1009015" y="7996555"/>
             <a:ext cx="1997710" cy="578485"/>
           </a:xfrm>
           <a:prstGeom prst="roundRect">
@@ -4271,7 +4203,7 @@
         </p:nvSpPr>
         <p:spPr>
           <a:xfrm>
-            <a:off x="2752725" y="6290310"/>
+            <a:off x="3935730" y="7244715"/>
             <a:ext cx="1974215" cy="578485"/>
           </a:xfrm>
           <a:prstGeom prst="roundRect">
@@ -4342,8 +4274,8 @@
         </p:nvCxnSpPr>
         <p:spPr>
           <a:xfrm rot="5400000" flipV="1">
-            <a:off x="1804670" y="8216900"/>
-            <a:ext cx="1160780" cy="735330"/>
+            <a:off x="1796098" y="8786813"/>
+            <a:ext cx="1168400" cy="744855"/>
           </a:xfrm>
           <a:prstGeom prst="curvedConnector2">
             <a:avLst/>
@@ -4375,7 +4307,7 @@
         </p:nvSpPr>
         <p:spPr>
           <a:xfrm>
-            <a:off x="3319851" y="10500916"/>
+            <a:off x="3319851" y="11079401"/>
             <a:ext cx="2321129" cy="578407"/>
           </a:xfrm>
           <a:prstGeom prst="roundRect">
@@ -4446,7 +4378,7 @@
         </p:nvCxnSpPr>
         <p:spPr>
           <a:xfrm rot="5400000" flipV="1">
-            <a:off x="3939540" y="9959975"/>
+            <a:off x="3939540" y="10538460"/>
             <a:ext cx="1047115" cy="34925"/>
           </a:xfrm>
           <a:prstGeom prst="curvedConnector3">
@@ -4481,7 +4413,7 @@
         </p:nvSpPr>
         <p:spPr>
           <a:xfrm>
-            <a:off x="10188011" y="8877221"/>
+            <a:off x="10188011" y="9455706"/>
             <a:ext cx="2321129" cy="578407"/>
           </a:xfrm>
           <a:prstGeom prst="roundRect">
@@ -4552,8 +4484,8 @@
         </p:nvCxnSpPr>
         <p:spPr>
           <a:xfrm rot="5400000" flipV="1">
-            <a:off x="10015538" y="7544118"/>
-            <a:ext cx="1722755" cy="943610"/>
+            <a:off x="10821035" y="8928100"/>
+            <a:ext cx="591820" cy="463550"/>
           </a:xfrm>
           <a:prstGeom prst="curvedConnector3">
             <a:avLst>
@@ -4587,7 +4519,7 @@
         </p:nvSpPr>
         <p:spPr>
           <a:xfrm>
-            <a:off x="7341870" y="10500995"/>
+            <a:off x="7341870" y="11079480"/>
             <a:ext cx="3385820" cy="578485"/>
           </a:xfrm>
           <a:prstGeom prst="roundRect">
@@ -4658,7 +4590,7 @@
         </p:nvCxnSpPr>
         <p:spPr>
           <a:xfrm rot="5400000" flipH="1" flipV="1">
-            <a:off x="5766753" y="9504363"/>
+            <a:off x="5766753" y="10082848"/>
             <a:ext cx="288925" cy="2861310"/>
           </a:xfrm>
           <a:prstGeom prst="curvedConnector4">
@@ -4697,7 +4629,7 @@
         </p:nvCxnSpPr>
         <p:spPr>
           <a:xfrm rot="5400000">
-            <a:off x="10370820" y="9812655"/>
+            <a:off x="10370820" y="10391140"/>
             <a:ext cx="1334770" cy="621030"/>
           </a:xfrm>
           <a:prstGeom prst="curvedConnector2">
@@ -4730,7 +4662,7 @@
         </p:nvSpPr>
         <p:spPr>
           <a:xfrm>
-            <a:off x="7585075" y="11808460"/>
+            <a:off x="7585075" y="12386945"/>
             <a:ext cx="2766060" cy="578485"/>
           </a:xfrm>
           <a:prstGeom prst="roundRect">
@@ -4801,7 +4733,7 @@
         </p:nvCxnSpPr>
         <p:spPr>
           <a:xfrm rot="5400000">
-            <a:off x="8636953" y="11410633"/>
+            <a:off x="8636953" y="11989118"/>
             <a:ext cx="728980" cy="66675"/>
           </a:xfrm>
           <a:prstGeom prst="curvedConnector3">
@@ -4839,8 +4771,8 @@
         </p:nvCxnSpPr>
         <p:spPr>
           <a:xfrm rot="10800000" flipV="1">
-            <a:off x="12098020" y="6865620"/>
-            <a:ext cx="1043305" cy="3175"/>
+            <a:off x="12578080" y="8575040"/>
+            <a:ext cx="847725" cy="3175"/>
           </a:xfrm>
           <a:prstGeom prst="curvedConnector2">
             <a:avLst/>
@@ -4872,7 +4804,7 @@
         </p:nvSpPr>
         <p:spPr>
           <a:xfrm>
-            <a:off x="14178280" y="1548130"/>
+            <a:off x="14570075" y="1685290"/>
             <a:ext cx="3150870" cy="578485"/>
           </a:xfrm>
           <a:prstGeom prst="roundRect">
@@ -4943,8 +4875,8 @@
         </p:nvCxnSpPr>
         <p:spPr>
           <a:xfrm rot="5400000">
-            <a:off x="14625320" y="1851025"/>
-            <a:ext cx="852805" cy="1403985"/>
+            <a:off x="14889798" y="1723708"/>
+            <a:ext cx="715645" cy="1795780"/>
           </a:xfrm>
           <a:prstGeom prst="curvedConnector2">
             <a:avLst/>
@@ -4976,7 +4908,7 @@
         </p:nvSpPr>
         <p:spPr>
           <a:xfrm>
-            <a:off x="13660755" y="5321935"/>
+            <a:off x="13983335" y="7088505"/>
             <a:ext cx="3150870" cy="578485"/>
           </a:xfrm>
           <a:prstGeom prst="roundRect">
@@ -5044,7 +4976,7 @@
         </p:nvSpPr>
         <p:spPr>
           <a:xfrm>
-            <a:off x="14570075" y="4179570"/>
+            <a:off x="14765655" y="5904230"/>
             <a:ext cx="2759075" cy="578485"/>
           </a:xfrm>
           <a:prstGeom prst="roundRect">
@@ -5115,8 +5047,8 @@
         </p:nvCxnSpPr>
         <p:spPr>
           <a:xfrm rot="5400000">
-            <a:off x="15311120" y="4683125"/>
-            <a:ext cx="563880" cy="713740"/>
+            <a:off x="15549245" y="6492240"/>
+            <a:ext cx="605790" cy="586740"/>
           </a:xfrm>
           <a:prstGeom prst="curvedConnector3">
             <a:avLst>
@@ -5153,8 +5085,8 @@
         </p:nvCxnSpPr>
         <p:spPr>
           <a:xfrm rot="5400000">
-            <a:off x="14608175" y="5948045"/>
-            <a:ext cx="675640" cy="580390"/>
+            <a:off x="14940280" y="7666990"/>
+            <a:ext cx="618490" cy="618490"/>
           </a:xfrm>
           <a:prstGeom prst="curvedConnector3">
             <a:avLst>
@@ -5294,7 +5226,7 @@
         </p:nvSpPr>
         <p:spPr>
           <a:xfrm>
-            <a:off x="7072630" y="8877300"/>
+            <a:off x="7072630" y="9455785"/>
             <a:ext cx="2604770" cy="578485"/>
           </a:xfrm>
           <a:prstGeom prst="roundRect">
@@ -5365,7 +5297,7 @@
         </p:nvCxnSpPr>
         <p:spPr>
           <a:xfrm flipV="1">
-            <a:off x="6138545" y="8877300"/>
+            <a:off x="6138545" y="9455785"/>
             <a:ext cx="2236470" cy="287655"/>
           </a:xfrm>
           <a:prstGeom prst="curvedConnector4">
@@ -5403,7 +5335,7 @@
         </p:nvCxnSpPr>
         <p:spPr>
           <a:xfrm rot="5400000" flipH="1">
-            <a:off x="7141845" y="8221980"/>
+            <a:off x="7141845" y="8800465"/>
             <a:ext cx="234315" cy="2232025"/>
           </a:xfrm>
           <a:prstGeom prst="curvedConnector4">
@@ -5439,7 +5371,7 @@
         </p:nvSpPr>
         <p:spPr>
           <a:xfrm>
-            <a:off x="7341870" y="13004800"/>
+            <a:off x="7341870" y="13583285"/>
             <a:ext cx="3385820" cy="578485"/>
           </a:xfrm>
           <a:prstGeom prst="roundRect">
@@ -5507,7 +5439,7 @@
         </p:nvSpPr>
         <p:spPr>
           <a:xfrm>
-            <a:off x="7341870" y="15210790"/>
+            <a:off x="7341870" y="15789275"/>
             <a:ext cx="3385820" cy="578485"/>
           </a:xfrm>
           <a:prstGeom prst="roundRect">
@@ -5578,7 +5510,7 @@
         </p:nvCxnSpPr>
         <p:spPr>
           <a:xfrm rot="5400000" flipV="1">
-            <a:off x="8692515" y="12661900"/>
+            <a:off x="8692515" y="13240385"/>
             <a:ext cx="617855" cy="66675"/>
           </a:xfrm>
           <a:prstGeom prst="curvedConnector3">
@@ -5613,7 +5545,7 @@
         </p:nvSpPr>
         <p:spPr>
           <a:xfrm>
-            <a:off x="7585075" y="14036675"/>
+            <a:off x="7585075" y="14615160"/>
             <a:ext cx="2766060" cy="578485"/>
           </a:xfrm>
           <a:prstGeom prst="roundRect">
@@ -5684,7 +5616,7 @@
         </p:nvCxnSpPr>
         <p:spPr>
           <a:xfrm rot="5400000">
-            <a:off x="8774430" y="13776325"/>
+            <a:off x="8774430" y="14354810"/>
             <a:ext cx="453390" cy="66675"/>
           </a:xfrm>
           <a:prstGeom prst="curvedConnector3">
@@ -5722,7 +5654,7 @@
         </p:nvCxnSpPr>
         <p:spPr>
           <a:xfrm rot="5400000" flipV="1">
-            <a:off x="8703628" y="14879638"/>
+            <a:off x="8703628" y="15458123"/>
             <a:ext cx="595630" cy="66675"/>
           </a:xfrm>
           <a:prstGeom prst="curvedConnector3">
@@ -5757,7 +5689,7 @@
         </p:nvSpPr>
         <p:spPr>
           <a:xfrm>
-            <a:off x="13425805" y="15337790"/>
+            <a:off x="13425805" y="15916275"/>
             <a:ext cx="3385820" cy="578485"/>
           </a:xfrm>
           <a:prstGeom prst="roundRect">
@@ -5825,7 +5757,7 @@
         </p:nvSpPr>
         <p:spPr>
           <a:xfrm>
-            <a:off x="7731125" y="16311245"/>
+            <a:off x="7731125" y="16889730"/>
             <a:ext cx="2766060" cy="578485"/>
           </a:xfrm>
           <a:prstGeom prst="roundRect">
@@ -5896,7 +5828,7 @@
         </p:nvCxnSpPr>
         <p:spPr>
           <a:xfrm rot="5400000" flipV="1">
-            <a:off x="8813165" y="16010255"/>
+            <a:off x="8813165" y="16588740"/>
             <a:ext cx="521970" cy="79375"/>
           </a:xfrm>
           <a:prstGeom prst="curvedConnector3">
@@ -5934,7 +5866,7 @@
         </p:nvCxnSpPr>
         <p:spPr>
           <a:xfrm>
-            <a:off x="10351135" y="14326235"/>
+            <a:off x="10351135" y="14904720"/>
             <a:ext cx="3074670" cy="1301115"/>
           </a:xfrm>
           <a:prstGeom prst="curvedConnector3">
@@ -5972,7 +5904,7 @@
         </p:nvCxnSpPr>
         <p:spPr>
           <a:xfrm flipV="1">
-            <a:off x="10497185" y="15627350"/>
+            <a:off x="10497185" y="16205835"/>
             <a:ext cx="2928620" cy="973455"/>
           </a:xfrm>
           <a:prstGeom prst="curvedConnector3">
@@ -6009,13 +5941,13 @@
           <p:nvPr/>
         </p:nvCxnSpPr>
         <p:spPr>
-          <a:xfrm rot="5400000" flipV="1">
-            <a:off x="3089593" y="7519353"/>
-            <a:ext cx="2006600" cy="705485"/>
+          <a:xfrm rot="5400000">
+            <a:off x="3869055" y="8399780"/>
+            <a:ext cx="1630680" cy="477520"/>
           </a:xfrm>
           <a:prstGeom prst="curvedConnector3">
             <a:avLst>
-              <a:gd name="adj1" fmla="val 49984"/>
+              <a:gd name="adj1" fmla="val 50000"/>
             </a:avLst>
           </a:prstGeom>
           <a:ln>
@@ -6045,7 +5977,7 @@
         </p:nvSpPr>
         <p:spPr>
           <a:xfrm>
-            <a:off x="1018561" y="500858"/>
+            <a:off x="3594756" y="405608"/>
             <a:ext cx="1994896" cy="578407"/>
           </a:xfrm>
           <a:prstGeom prst="roundRect">
@@ -6113,7 +6045,7 @@
         </p:nvSpPr>
         <p:spPr>
           <a:xfrm>
-            <a:off x="819150" y="1548130"/>
+            <a:off x="3011170" y="1685290"/>
             <a:ext cx="3131820" cy="578485"/>
           </a:xfrm>
           <a:prstGeom prst="roundRect">
@@ -6124,7 +6056,7 @@
           <a:noFill/>
           <a:ln w="19050">
             <a:solidFill>
-              <a:schemeClr val="accent2"/>
+              <a:schemeClr val="accent6"/>
             </a:solidFill>
           </a:ln>
           <a:extLst>
@@ -6160,14 +6092,14 @@
             <a:r>
               <a:rPr lang="fr-FR" altLang="en-US" sz="2065" b="1">
                 <a:solidFill>
-                  <a:schemeClr val="accent2"/>
+                  <a:schemeClr val="accent6"/>
                 </a:solidFill>
               </a:rPr>
-              <a:t>bdy_process_effec_data</a:t>
+              <a:t>bdy_check_colonies</a:t>
             </a:r>
             <a:endParaRPr lang="fr-FR" altLang="en-US" sz="2065" b="1">
               <a:solidFill>
-                <a:schemeClr val="accent2"/>
+                <a:schemeClr val="accent6"/>
               </a:solidFill>
             </a:endParaRPr>
           </a:p>
@@ -6183,47 +6115,9 @@
           <p:nvPr/>
         </p:nvCxnSpPr>
         <p:spPr>
-          <a:xfrm rot="5400000" flipV="1">
-            <a:off x="1966278" y="1129348"/>
-            <a:ext cx="468630" cy="368935"/>
-          </a:xfrm>
-          <a:prstGeom prst="curvedConnector3">
-            <a:avLst>
-              <a:gd name="adj1" fmla="val 49932"/>
-            </a:avLst>
-          </a:prstGeom>
-          <a:ln>
-            <a:tailEnd type="arrow" w="med" len="med"/>
-          </a:ln>
-        </p:spPr>
-        <p:style>
-          <a:lnRef idx="3">
-            <a:schemeClr val="accent1"/>
-          </a:lnRef>
-          <a:fillRef idx="0">
-            <a:srgbClr val="FFFFFF"/>
-          </a:fillRef>
-          <a:effectRef idx="0">
-            <a:srgbClr val="FFFFFF"/>
-          </a:effectRef>
-          <a:fontRef idx="minor">
-            <a:schemeClr val="tx1"/>
-          </a:fontRef>
-        </p:style>
-      </p:cxnSp>
-      <p:cxnSp>
-        <p:nvCxnSpPr>
-          <p:cNvPr id="84" name="Curved Connector 83"/>
-          <p:cNvCxnSpPr>
-            <a:stCxn id="80" idx="3"/>
-            <a:endCxn id="10" idx="1"/>
-          </p:cNvCxnSpPr>
-          <p:nvPr/>
-        </p:nvCxnSpPr>
-        <p:spPr>
-          <a:xfrm flipV="1">
-            <a:off x="3950970" y="833755"/>
-            <a:ext cx="2477770" cy="1003935"/>
+          <a:xfrm rot="5400000">
+            <a:off x="4234180" y="1327150"/>
+            <a:ext cx="701040" cy="15240"/>
           </a:xfrm>
           <a:prstGeom prst="curvedConnector3">
             <a:avLst>
@@ -6231,88 +6125,11 @@
             </a:avLst>
           </a:prstGeom>
           <a:ln>
-            <a:tailEnd type="arrow"/>
-          </a:ln>
-        </p:spPr>
-        <p:style>
-          <a:lnRef idx="2">
-            <a:schemeClr val="accent1"/>
-          </a:lnRef>
-          <a:fillRef idx="0">
-            <a:srgbClr val="FFFFFF"/>
-          </a:fillRef>
-          <a:effectRef idx="0">
-            <a:srgbClr val="FFFFFF"/>
-          </a:effectRef>
-          <a:fontRef idx="minor">
-            <a:schemeClr val="tx1"/>
-          </a:fontRef>
-        </p:style>
-      </p:cxnSp>
-      <p:cxnSp>
-        <p:nvCxnSpPr>
-          <p:cNvPr id="86" name="Curved Connector 85"/>
-          <p:cNvCxnSpPr>
-            <a:stCxn id="80" idx="2"/>
-            <a:endCxn id="42" idx="0"/>
-          </p:cNvCxnSpPr>
-          <p:nvPr/>
-        </p:nvCxnSpPr>
-        <p:spPr>
-          <a:xfrm rot="5400000" flipV="1">
-            <a:off x="980758" y="3530918"/>
-            <a:ext cx="4163695" cy="1355090"/>
-          </a:xfrm>
-          <a:prstGeom prst="curvedConnector3">
-            <a:avLst>
-              <a:gd name="adj1" fmla="val 50000"/>
-            </a:avLst>
-          </a:prstGeom>
-          <a:ln>
-            <a:tailEnd type="arrow"/>
-          </a:ln>
-        </p:spPr>
-        <p:style>
-          <a:lnRef idx="2">
-            <a:schemeClr val="accent1"/>
-          </a:lnRef>
-          <a:fillRef idx="0">
-            <a:srgbClr val="FFFFFF"/>
-          </a:fillRef>
-          <a:effectRef idx="0">
-            <a:srgbClr val="FFFFFF"/>
-          </a:effectRef>
-          <a:fontRef idx="minor">
-            <a:schemeClr val="tx1"/>
-          </a:fontRef>
-        </p:style>
-      </p:cxnSp>
-      <p:cxnSp>
-        <p:nvCxnSpPr>
-          <p:cNvPr id="87" name="Curved Connector 86"/>
-          <p:cNvCxnSpPr>
-            <a:stCxn id="80" idx="1"/>
-            <a:endCxn id="41" idx="0"/>
-          </p:cNvCxnSpPr>
-          <p:nvPr/>
-        </p:nvCxnSpPr>
-        <p:spPr>
-          <a:xfrm rot="10800000" flipH="1" flipV="1">
-            <a:off x="819150" y="1837690"/>
-            <a:ext cx="1198245" cy="5588000"/>
-          </a:xfrm>
-          <a:prstGeom prst="curvedConnector4">
-            <a:avLst>
-              <a:gd name="adj1" fmla="val -19873"/>
-              <a:gd name="adj2" fmla="val 52591"/>
-            </a:avLst>
-          </a:prstGeom>
-          <a:ln>
-            <a:tailEnd type="arrow"/>
-          </a:ln>
-        </p:spPr>
-        <p:style>
-          <a:lnRef idx="2">
+            <a:tailEnd type="arrow" w="med" len="med"/>
+          </a:ln>
+        </p:spPr>
+        <p:style>
+          <a:lnRef idx="3">
             <a:schemeClr val="accent1"/>
           </a:lnRef>
           <a:fillRef idx="0">
@@ -6334,8 +6151,8 @@
         </p:nvSpPr>
         <p:spPr>
           <a:xfrm>
-            <a:off x="4294505" y="2691765"/>
-            <a:ext cx="3131820" cy="578485"/>
+            <a:off x="100965" y="5614670"/>
+            <a:ext cx="2370455" cy="578485"/>
           </a:xfrm>
           <a:prstGeom prst="roundRect">
             <a:avLst>
@@ -6345,7 +6162,7 @@
           <a:noFill/>
           <a:ln w="19050">
             <a:solidFill>
-              <a:schemeClr val="accent2"/>
+              <a:schemeClr val="accent6"/>
             </a:solidFill>
           </a:ln>
           <a:extLst>
@@ -6381,14 +6198,14 @@
             <a:r>
               <a:rPr lang="fr-FR" altLang="en-US" sz="2065" b="1">
                 <a:solidFill>
-                  <a:schemeClr val="accent2"/>
+                  <a:schemeClr val="accent6"/>
                 </a:solidFill>
               </a:rPr>
-              <a:t>bdy_group_colonies</a:t>
+              <a:t>bdy_clustering</a:t>
             </a:r>
             <a:endParaRPr lang="fr-FR" altLang="en-US" sz="2065" b="1">
               <a:solidFill>
-                <a:schemeClr val="accent2"/>
+                <a:schemeClr val="accent6"/>
               </a:solidFill>
             </a:endParaRPr>
           </a:p>
@@ -6402,7 +6219,7 @@
         </p:nvCxnSpPr>
         <p:spPr>
           <a:xfrm flipH="1">
-            <a:off x="-53975" y="3717290"/>
+            <a:off x="0" y="4512945"/>
             <a:ext cx="18102580" cy="45720"/>
           </a:xfrm>
           <a:prstGeom prst="line">
@@ -6441,7 +6258,7 @@
         </p:nvSpPr>
         <p:spPr>
           <a:xfrm>
-            <a:off x="16170275" y="3268345"/>
+            <a:off x="16170275" y="3968750"/>
             <a:ext cx="1710690" cy="382270"/>
           </a:xfrm>
           <a:prstGeom prst="rect">
@@ -6474,6 +6291,630 @@
           </a:p>
         </p:txBody>
       </p:sp>
+      <p:sp>
+        <p:nvSpPr>
+          <p:cNvPr id="2" name="Rounded Rectangle 1"/>
+          <p:cNvSpPr/>
+          <p:nvPr/>
+        </p:nvSpPr>
+        <p:spPr>
+          <a:xfrm>
+            <a:off x="1009015" y="3112770"/>
+            <a:ext cx="2665730" cy="578485"/>
+          </a:xfrm>
+          <a:prstGeom prst="roundRect">
+            <a:avLst>
+              <a:gd name="adj" fmla="val 50000"/>
+            </a:avLst>
+          </a:prstGeom>
+          <a:noFill/>
+          <a:ln w="19050">
+            <a:solidFill>
+              <a:schemeClr val="accent5"/>
+            </a:solidFill>
+          </a:ln>
+          <a:extLst>
+            <a:ext uri="{909E8E84-426E-40DD-AFC4-6F175D3DCCD1}">
+              <a14:hiddenFill xmlns:a14="http://schemas.microsoft.com/office/drawing/2010/main">
+                <a:solidFill>
+                  <a:schemeClr val="accent1"/>
+                </a:solidFill>
+              </a14:hiddenFill>
+            </a:ext>
+          </a:extLst>
+        </p:spPr>
+        <p:style>
+          <a:lnRef idx="2">
+            <a:schemeClr val="accent1">
+              <a:lumMod val="75000"/>
+            </a:schemeClr>
+          </a:lnRef>
+          <a:fillRef idx="1">
+            <a:schemeClr val="accent1"/>
+          </a:fillRef>
+          <a:effectRef idx="0">
+            <a:srgbClr val="FFFFFF"/>
+          </a:effectRef>
+          <a:fontRef idx="minor">
+            <a:schemeClr val="lt1"/>
+          </a:fontRef>
+        </p:style>
+        <p:txBody>
+          <a:bodyPr rtlCol="0" anchor="ctr"/>
+          <a:p>
+            <a:pPr algn="ctr"/>
+            <a:r>
+              <a:rPr lang="fr-FR" altLang="en-US" sz="2065" b="1">
+                <a:solidFill>
+                  <a:schemeClr val="accent5"/>
+                </a:solidFill>
+              </a:rPr>
+              <a:t>clean effectif data</a:t>
+            </a:r>
+            <a:endParaRPr lang="fr-FR" altLang="en-US" sz="2065" b="1">
+              <a:solidFill>
+                <a:schemeClr val="accent5"/>
+              </a:solidFill>
+            </a:endParaRPr>
+          </a:p>
+        </p:txBody>
+      </p:sp>
+      <p:sp>
+        <p:nvSpPr>
+          <p:cNvPr id="3" name="Rounded Rectangle 2"/>
+          <p:cNvSpPr/>
+          <p:nvPr/>
+        </p:nvSpPr>
+        <p:spPr>
+          <a:xfrm>
+            <a:off x="3319780" y="5492750"/>
+            <a:ext cx="3131820" cy="578485"/>
+          </a:xfrm>
+          <a:prstGeom prst="roundRect">
+            <a:avLst>
+              <a:gd name="adj" fmla="val 50000"/>
+            </a:avLst>
+          </a:prstGeom>
+          <a:noFill/>
+          <a:ln w="19050">
+            <a:solidFill>
+              <a:schemeClr val="accent6"/>
+            </a:solidFill>
+          </a:ln>
+          <a:extLst>
+            <a:ext uri="{909E8E84-426E-40DD-AFC4-6F175D3DCCD1}">
+              <a14:hiddenFill xmlns:a14="http://schemas.microsoft.com/office/drawing/2010/main">
+                <a:solidFill>
+                  <a:schemeClr val="accent1"/>
+                </a:solidFill>
+              </a14:hiddenFill>
+            </a:ext>
+          </a:extLst>
+        </p:spPr>
+        <p:style>
+          <a:lnRef idx="2">
+            <a:schemeClr val="accent1">
+              <a:lumMod val="75000"/>
+            </a:schemeClr>
+          </a:lnRef>
+          <a:fillRef idx="1">
+            <a:schemeClr val="accent1"/>
+          </a:fillRef>
+          <a:effectRef idx="0">
+            <a:srgbClr val="FFFFFF"/>
+          </a:effectRef>
+          <a:fontRef idx="minor">
+            <a:schemeClr val="lt1"/>
+          </a:fontRef>
+        </p:style>
+        <p:txBody>
+          <a:bodyPr rtlCol="0" anchor="ctr"/>
+          <a:p>
+            <a:pPr algn="ctr"/>
+            <a:r>
+              <a:rPr lang="fr-FR" altLang="en-US" sz="2065" b="1">
+                <a:solidFill>
+                  <a:schemeClr val="accent6"/>
+                </a:solidFill>
+              </a:rPr>
+              <a:t>bdy_process_count_data</a:t>
+            </a:r>
+            <a:endParaRPr lang="fr-FR" altLang="en-US" sz="2065" b="1">
+              <a:solidFill>
+                <a:schemeClr val="accent6"/>
+              </a:solidFill>
+            </a:endParaRPr>
+          </a:p>
+        </p:txBody>
+      </p:sp>
+      <p:cxnSp>
+        <p:nvCxnSpPr>
+          <p:cNvPr id="5" name="Curved Connector 4"/>
+          <p:cNvCxnSpPr>
+            <a:stCxn id="10" idx="3"/>
+            <a:endCxn id="9" idx="1"/>
+          </p:cNvCxnSpPr>
+          <p:nvPr/>
+        </p:nvCxnSpPr>
+        <p:spPr>
+          <a:xfrm flipV="1">
+            <a:off x="7585075" y="1837690"/>
+            <a:ext cx="1480820" cy="1564640"/>
+          </a:xfrm>
+          <a:prstGeom prst="curvedConnector3">
+            <a:avLst>
+              <a:gd name="adj1" fmla="val 50000"/>
+            </a:avLst>
+          </a:prstGeom>
+          <a:ln>
+            <a:tailEnd type="arrow" w="med" len="med"/>
+          </a:ln>
+        </p:spPr>
+        <p:style>
+          <a:lnRef idx="3">
+            <a:schemeClr val="accent1"/>
+          </a:lnRef>
+          <a:fillRef idx="0">
+            <a:srgbClr val="FFFFFF"/>
+          </a:fillRef>
+          <a:effectRef idx="0">
+            <a:srgbClr val="FFFFFF"/>
+          </a:effectRef>
+          <a:fontRef idx="minor">
+            <a:schemeClr val="tx1"/>
+          </a:fontRef>
+        </p:style>
+      </p:cxnSp>
+      <p:cxnSp>
+        <p:nvCxnSpPr>
+          <p:cNvPr id="6" name="Curved Connector 5"/>
+          <p:cNvCxnSpPr>
+            <a:stCxn id="80" idx="2"/>
+            <a:endCxn id="2" idx="0"/>
+          </p:cNvCxnSpPr>
+          <p:nvPr/>
+        </p:nvCxnSpPr>
+        <p:spPr>
+          <a:xfrm rot="5400000">
+            <a:off x="3034983" y="1570673"/>
+            <a:ext cx="848995" cy="2235200"/>
+          </a:xfrm>
+          <a:prstGeom prst="curvedConnector3">
+            <a:avLst>
+              <a:gd name="adj1" fmla="val 50000"/>
+            </a:avLst>
+          </a:prstGeom>
+          <a:ln>
+            <a:tailEnd type="arrow" w="med" len="med"/>
+          </a:ln>
+        </p:spPr>
+        <p:style>
+          <a:lnRef idx="3">
+            <a:schemeClr val="accent1"/>
+          </a:lnRef>
+          <a:fillRef idx="0">
+            <a:srgbClr val="FFFFFF"/>
+          </a:fillRef>
+          <a:effectRef idx="0">
+            <a:srgbClr val="FFFFFF"/>
+          </a:effectRef>
+          <a:fontRef idx="minor">
+            <a:schemeClr val="tx1"/>
+          </a:fontRef>
+        </p:style>
+      </p:cxnSp>
+      <p:cxnSp>
+        <p:nvCxnSpPr>
+          <p:cNvPr id="7" name="Curved Connector 6"/>
+          <p:cNvCxnSpPr>
+            <a:stCxn id="2" idx="2"/>
+            <a:endCxn id="3" idx="0"/>
+          </p:cNvCxnSpPr>
+          <p:nvPr/>
+        </p:nvCxnSpPr>
+        <p:spPr>
+          <a:xfrm rot="5400000" flipV="1">
+            <a:off x="2713038" y="3320098"/>
+            <a:ext cx="1801495" cy="2543810"/>
+          </a:xfrm>
+          <a:prstGeom prst="curvedConnector3">
+            <a:avLst>
+              <a:gd name="adj1" fmla="val 50000"/>
+            </a:avLst>
+          </a:prstGeom>
+          <a:ln>
+            <a:tailEnd type="arrow"/>
+          </a:ln>
+        </p:spPr>
+        <p:style>
+          <a:lnRef idx="2">
+            <a:schemeClr val="accent1"/>
+          </a:lnRef>
+          <a:fillRef idx="0">
+            <a:srgbClr val="FFFFFF"/>
+          </a:fillRef>
+          <a:effectRef idx="0">
+            <a:srgbClr val="FFFFFF"/>
+          </a:effectRef>
+          <a:fontRef idx="minor">
+            <a:schemeClr val="tx1"/>
+          </a:fontRef>
+        </p:style>
+      </p:cxnSp>
+      <p:cxnSp>
+        <p:nvCxnSpPr>
+          <p:cNvPr id="8" name="Curved Connector 7"/>
+          <p:cNvCxnSpPr>
+            <a:stCxn id="10" idx="2"/>
+            <a:endCxn id="3" idx="0"/>
+          </p:cNvCxnSpPr>
+          <p:nvPr/>
+        </p:nvCxnSpPr>
+        <p:spPr>
+          <a:xfrm rot="5400000">
+            <a:off x="4835843" y="3741103"/>
+            <a:ext cx="1801495" cy="1701800"/>
+          </a:xfrm>
+          <a:prstGeom prst="curvedConnector3">
+            <a:avLst>
+              <a:gd name="adj1" fmla="val 50000"/>
+            </a:avLst>
+          </a:prstGeom>
+          <a:ln>
+            <a:tailEnd type="arrow"/>
+          </a:ln>
+        </p:spPr>
+        <p:style>
+          <a:lnRef idx="2">
+            <a:schemeClr val="accent1"/>
+          </a:lnRef>
+          <a:fillRef idx="0">
+            <a:srgbClr val="FFFFFF"/>
+          </a:fillRef>
+          <a:effectRef idx="0">
+            <a:srgbClr val="FFFFFF"/>
+          </a:effectRef>
+          <a:fontRef idx="minor">
+            <a:schemeClr val="tx1"/>
+          </a:fontRef>
+        </p:style>
+      </p:cxnSp>
+      <p:sp>
+        <p:nvSpPr>
+          <p:cNvPr id="27" name="Rounded Rectangle 26"/>
+          <p:cNvSpPr/>
+          <p:nvPr/>
+        </p:nvSpPr>
+        <p:spPr>
+          <a:xfrm>
+            <a:off x="7341870" y="5325745"/>
+            <a:ext cx="1974215" cy="578485"/>
+          </a:xfrm>
+          <a:prstGeom prst="roundRect">
+            <a:avLst>
+              <a:gd name="adj" fmla="val 50000"/>
+            </a:avLst>
+          </a:prstGeom>
+          <a:noFill/>
+          <a:ln w="19050">
+            <a:solidFill>
+              <a:schemeClr val="accent5"/>
+            </a:solidFill>
+          </a:ln>
+          <a:extLst>
+            <a:ext uri="{909E8E84-426E-40DD-AFC4-6F175D3DCCD1}">
+              <a14:hiddenFill xmlns:a14="http://schemas.microsoft.com/office/drawing/2010/main">
+                <a:solidFill>
+                  <a:schemeClr val="accent1"/>
+                </a:solidFill>
+              </a14:hiddenFill>
+            </a:ext>
+          </a:extLst>
+        </p:spPr>
+        <p:style>
+          <a:lnRef idx="2">
+            <a:schemeClr val="accent1">
+              <a:lumMod val="75000"/>
+            </a:schemeClr>
+          </a:lnRef>
+          <a:fillRef idx="1">
+            <a:schemeClr val="accent1"/>
+          </a:fillRef>
+          <a:effectRef idx="0">
+            <a:srgbClr val="FFFFFF"/>
+          </a:effectRef>
+          <a:fontRef idx="minor">
+            <a:schemeClr val="lt1"/>
+          </a:fontRef>
+        </p:style>
+        <p:txBody>
+          <a:bodyPr rtlCol="0" anchor="ctr"/>
+          <a:p>
+            <a:pPr algn="ctr"/>
+            <a:r>
+              <a:rPr lang="fr-FR" altLang="en-US" sz="2065" b="1">
+                <a:solidFill>
+                  <a:schemeClr val="accent5"/>
+                </a:solidFill>
+              </a:rPr>
+              <a:t>colonies_sp</a:t>
+            </a:r>
+            <a:endParaRPr lang="fr-FR" altLang="en-US" sz="2065" b="1">
+              <a:solidFill>
+                <a:schemeClr val="accent5"/>
+              </a:solidFill>
+            </a:endParaRPr>
+          </a:p>
+        </p:txBody>
+      </p:sp>
+      <p:cxnSp>
+        <p:nvCxnSpPr>
+          <p:cNvPr id="34" name="Curved Connector 33"/>
+          <p:cNvCxnSpPr>
+            <a:stCxn id="80" idx="2"/>
+            <a:endCxn id="10" idx="0"/>
+          </p:cNvCxnSpPr>
+          <p:nvPr/>
+        </p:nvCxnSpPr>
+        <p:spPr>
+          <a:xfrm rot="5400000" flipV="1">
+            <a:off x="5157788" y="1683068"/>
+            <a:ext cx="848995" cy="2010410"/>
+          </a:xfrm>
+          <a:prstGeom prst="curvedConnector3">
+            <a:avLst>
+              <a:gd name="adj1" fmla="val 50000"/>
+            </a:avLst>
+          </a:prstGeom>
+          <a:ln>
+            <a:tailEnd type="arrow"/>
+          </a:ln>
+        </p:spPr>
+        <p:style>
+          <a:lnRef idx="2">
+            <a:schemeClr val="accent1"/>
+          </a:lnRef>
+          <a:fillRef idx="0">
+            <a:srgbClr val="FFFFFF"/>
+          </a:fillRef>
+          <a:effectRef idx="0">
+            <a:srgbClr val="FFFFFF"/>
+          </a:effectRef>
+          <a:fontRef idx="minor">
+            <a:schemeClr val="tx1"/>
+          </a:fontRef>
+        </p:style>
+      </p:cxnSp>
+      <p:cxnSp>
+        <p:nvCxnSpPr>
+          <p:cNvPr id="35" name="Curved Connector 34"/>
+          <p:cNvCxnSpPr>
+            <a:stCxn id="3" idx="3"/>
+            <a:endCxn id="27" idx="1"/>
+          </p:cNvCxnSpPr>
+          <p:nvPr/>
+        </p:nvCxnSpPr>
+        <p:spPr>
+          <a:xfrm flipV="1">
+            <a:off x="6451600" y="5615305"/>
+            <a:ext cx="890270" cy="167005"/>
+          </a:xfrm>
+          <a:prstGeom prst="curvedConnector3">
+            <a:avLst>
+              <a:gd name="adj1" fmla="val 50000"/>
+            </a:avLst>
+          </a:prstGeom>
+          <a:ln>
+            <a:tailEnd type="arrow" w="med" len="med"/>
+          </a:ln>
+        </p:spPr>
+        <p:style>
+          <a:lnRef idx="3">
+            <a:schemeClr val="accent1"/>
+          </a:lnRef>
+          <a:fillRef idx="0">
+            <a:srgbClr val="FFFFFF"/>
+          </a:fillRef>
+          <a:effectRef idx="0">
+            <a:srgbClr val="FFFFFF"/>
+          </a:effectRef>
+          <a:fontRef idx="minor">
+            <a:schemeClr val="tx1"/>
+          </a:fontRef>
+        </p:style>
+      </p:cxnSp>
+      <p:cxnSp>
+        <p:nvCxnSpPr>
+          <p:cNvPr id="37" name="Curved Connector 36"/>
+          <p:cNvCxnSpPr>
+            <a:stCxn id="27" idx="3"/>
+            <a:endCxn id="14" idx="1"/>
+          </p:cNvCxnSpPr>
+          <p:nvPr/>
+        </p:nvCxnSpPr>
+        <p:spPr>
+          <a:xfrm flipV="1">
+            <a:off x="9316085" y="5340350"/>
+            <a:ext cx="1422400" cy="274955"/>
+          </a:xfrm>
+          <a:prstGeom prst="curvedConnector3">
+            <a:avLst>
+              <a:gd name="adj1" fmla="val 50000"/>
+            </a:avLst>
+          </a:prstGeom>
+          <a:ln>
+            <a:tailEnd type="arrow"/>
+          </a:ln>
+        </p:spPr>
+        <p:style>
+          <a:lnRef idx="2">
+            <a:schemeClr val="accent1"/>
+          </a:lnRef>
+          <a:fillRef idx="0">
+            <a:srgbClr val="FFFFFF"/>
+          </a:fillRef>
+          <a:effectRef idx="0">
+            <a:srgbClr val="FFFFFF"/>
+          </a:effectRef>
+          <a:fontRef idx="minor">
+            <a:schemeClr val="tx1"/>
+          </a:fontRef>
+        </p:style>
+      </p:cxnSp>
+      <p:cxnSp>
+        <p:nvCxnSpPr>
+          <p:cNvPr id="38" name="Curved Connector 37"/>
+          <p:cNvCxnSpPr>
+            <a:stCxn id="3" idx="2"/>
+            <a:endCxn id="42" idx="0"/>
+          </p:cNvCxnSpPr>
+          <p:nvPr/>
+        </p:nvCxnSpPr>
+        <p:spPr>
+          <a:xfrm rot="5400000" flipV="1">
+            <a:off x="4317365" y="6638925"/>
+            <a:ext cx="1173480" cy="37465"/>
+          </a:xfrm>
+          <a:prstGeom prst="curvedConnector3">
+            <a:avLst>
+              <a:gd name="adj1" fmla="val 49973"/>
+            </a:avLst>
+          </a:prstGeom>
+          <a:ln>
+            <a:tailEnd type="arrow" w="med" len="med"/>
+          </a:ln>
+        </p:spPr>
+        <p:style>
+          <a:lnRef idx="3">
+            <a:schemeClr val="accent1"/>
+          </a:lnRef>
+          <a:fillRef idx="0">
+            <a:srgbClr val="FFFFFF"/>
+          </a:fillRef>
+          <a:effectRef idx="0">
+            <a:srgbClr val="FFFFFF"/>
+          </a:effectRef>
+          <a:fontRef idx="minor">
+            <a:schemeClr val="tx1"/>
+          </a:fontRef>
+        </p:style>
+      </p:cxnSp>
+      <p:cxnSp>
+        <p:nvCxnSpPr>
+          <p:cNvPr id="44" name="Curved Connector 43"/>
+          <p:cNvCxnSpPr>
+            <a:stCxn id="3" idx="2"/>
+            <a:endCxn id="41" idx="0"/>
+          </p:cNvCxnSpPr>
+          <p:nvPr/>
+        </p:nvCxnSpPr>
+        <p:spPr>
+          <a:xfrm rot="5400000">
+            <a:off x="2484120" y="5594985"/>
+            <a:ext cx="1925320" cy="2877820"/>
+          </a:xfrm>
+          <a:prstGeom prst="curvedConnector3">
+            <a:avLst>
+              <a:gd name="adj1" fmla="val 50000"/>
+            </a:avLst>
+          </a:prstGeom>
+          <a:ln>
+            <a:tailEnd type="arrow" w="med" len="med"/>
+          </a:ln>
+        </p:spPr>
+        <p:style>
+          <a:lnRef idx="3">
+            <a:schemeClr val="accent1"/>
+          </a:lnRef>
+          <a:fillRef idx="0">
+            <a:srgbClr val="FFFFFF"/>
+          </a:fillRef>
+          <a:effectRef idx="0">
+            <a:srgbClr val="FFFFFF"/>
+          </a:effectRef>
+          <a:fontRef idx="minor">
+            <a:schemeClr val="tx1"/>
+          </a:fontRef>
+        </p:style>
+      </p:cxnSp>
+      <p:cxnSp>
+        <p:nvCxnSpPr>
+          <p:cNvPr id="46" name="Curved Connector 45"/>
+          <p:cNvCxnSpPr>
+            <a:stCxn id="3" idx="1"/>
+            <a:endCxn id="88" idx="0"/>
+          </p:cNvCxnSpPr>
+          <p:nvPr/>
+        </p:nvCxnSpPr>
+        <p:spPr>
+          <a:xfrm rot="10800000">
+            <a:off x="1286510" y="5614670"/>
+            <a:ext cx="2033270" cy="167640"/>
+          </a:xfrm>
+          <a:prstGeom prst="curvedConnector4">
+            <a:avLst>
+              <a:gd name="adj1" fmla="val 20862"/>
+              <a:gd name="adj2" fmla="val 314773"/>
+            </a:avLst>
+          </a:prstGeom>
+          <a:ln>
+            <a:tailEnd type="arrow" w="med" len="med"/>
+          </a:ln>
+        </p:spPr>
+        <p:style>
+          <a:lnRef idx="3">
+            <a:schemeClr val="accent1"/>
+          </a:lnRef>
+          <a:fillRef idx="0">
+            <a:srgbClr val="FFFFFF"/>
+          </a:fillRef>
+          <a:effectRef idx="0">
+            <a:srgbClr val="FFFFFF"/>
+          </a:effectRef>
+          <a:fontRef idx="minor">
+            <a:schemeClr val="tx1"/>
+          </a:fontRef>
+        </p:style>
+      </p:cxnSp>
+      <p:cxnSp>
+        <p:nvCxnSpPr>
+          <p:cNvPr id="81" name="Curved Connector 80"/>
+          <p:cNvCxnSpPr>
+            <a:stCxn id="88" idx="2"/>
+            <a:endCxn id="3" idx="1"/>
+          </p:cNvCxnSpPr>
+          <p:nvPr/>
+        </p:nvCxnSpPr>
+        <p:spPr>
+          <a:xfrm rot="5400000" flipH="1" flipV="1">
+            <a:off x="2098040" y="4970780"/>
+            <a:ext cx="410845" cy="2033270"/>
+          </a:xfrm>
+          <a:prstGeom prst="curvedConnector4">
+            <a:avLst>
+              <a:gd name="adj1" fmla="val -57883"/>
+              <a:gd name="adj2" fmla="val 79122"/>
+            </a:avLst>
+          </a:prstGeom>
+          <a:ln>
+            <a:tailEnd type="arrow" w="med" len="med"/>
+          </a:ln>
+        </p:spPr>
+        <p:style>
+          <a:lnRef idx="3">
+            <a:schemeClr val="accent1"/>
+          </a:lnRef>
+          <a:fillRef idx="0">
+            <a:srgbClr val="FFFFFF"/>
+          </a:fillRef>
+          <a:effectRef idx="0">
+            <a:srgbClr val="FFFFFF"/>
+          </a:effectRef>
+          <a:fontRef idx="minor">
+            <a:schemeClr val="tx1"/>
+          </a:fontRef>
+        </p:style>
+      </p:cxnSp>
     </p:spTree>
   </p:cSld>
   <p:clrMapOvr>

</xml_diff>